<commit_message>
finish editing , style it better and validate everything
</commit_message>
<xml_diff>
--- a/interceptors.pptx
+++ b/interceptors.pptx
@@ -9224,7 +9224,7 @@
         </p:nvSpPr>
         <p:spPr>
           <a:xfrm>
-            <a:off x="2651760" y="4206240"/>
+            <a:off x="2725380" y="3962150"/>
             <a:ext cx="1188720" cy="228600"/>
           </a:xfrm>
           <a:prstGeom prst="roundRect">
@@ -9258,7 +9258,7 @@
         </p:nvSpPr>
         <p:spPr>
           <a:xfrm>
-            <a:off x="2697480" y="4224528"/>
+            <a:off x="2775496" y="3993626"/>
             <a:ext cx="1097280" cy="201168"/>
           </a:xfrm>
           <a:prstGeom prst="rect">
@@ -9297,7 +9297,7 @@
         </p:nvSpPr>
         <p:spPr>
           <a:xfrm>
-            <a:off x="4572000" y="4206240"/>
+            <a:off x="5303155" y="3975338"/>
             <a:ext cx="1188720" cy="228600"/>
           </a:xfrm>
           <a:prstGeom prst="roundRect">
@@ -9331,7 +9331,7 @@
         </p:nvSpPr>
         <p:spPr>
           <a:xfrm>
-            <a:off x="4617720" y="4224528"/>
+            <a:off x="5348875" y="3993626"/>
             <a:ext cx="1097280" cy="201168"/>
           </a:xfrm>
           <a:prstGeom prst="rect">
@@ -9359,6 +9359,93 @@
               <a:t>Node.js · Express</a:t>
             </a:r>
             <a:endParaRPr lang="en-US" sz="900" dirty="0"/>
+          </a:p>
+        </p:txBody>
+      </p:sp>
+      <p:sp>
+        <p:nvSpPr>
+          <p:cNvPr id="252" name="Shape 2">
+            <a:extLst>
+              <a:ext uri="{FF2B5EF4-FFF2-40B4-BE49-F238E27FC236}">
+                <a16:creationId xmlns:a16="http://schemas.microsoft.com/office/drawing/2014/main" id="{A0AC14C4-88C6-FDFB-AD19-1B287232DAB4}"/>
+              </a:ext>
+            </a:extLst>
+          </p:cNvPr>
+          <p:cNvSpPr/>
+          <p:nvPr/>
+        </p:nvSpPr>
+        <p:spPr>
+          <a:xfrm>
+            <a:off x="2725785" y="4336140"/>
+            <a:ext cx="3767327" cy="301171"/>
+          </a:xfrm>
+          <a:prstGeom prst="roundRect">
+            <a:avLst>
+              <a:gd name="adj" fmla="val 20000"/>
+            </a:avLst>
+          </a:prstGeom>
+          <a:solidFill>
+            <a:srgbClr val="FBEFFF"/>
+          </a:solidFill>
+          <a:ln w="9525">
+            <a:solidFill>
+              <a:srgbClr val="8250DF"/>
+            </a:solidFill>
+            <a:prstDash val="solid"/>
+          </a:ln>
+        </p:spPr>
+        <p:txBody>
+          <a:bodyPr/>
+          <a:lstStyle/>
+          <a:p>
+            <a:endParaRPr lang="en-US"/>
+          </a:p>
+        </p:txBody>
+      </p:sp>
+      <p:sp>
+        <p:nvSpPr>
+          <p:cNvPr id="253" name="Text 246">
+            <a:extLst>
+              <a:ext uri="{FF2B5EF4-FFF2-40B4-BE49-F238E27FC236}">
+                <a16:creationId xmlns:a16="http://schemas.microsoft.com/office/drawing/2014/main" id="{30147E3B-117A-EC0C-0C46-400A0A8D36F1}"/>
+              </a:ext>
+            </a:extLst>
+          </p:cNvPr>
+          <p:cNvSpPr/>
+          <p:nvPr/>
+        </p:nvSpPr>
+        <p:spPr>
+          <a:xfrm>
+            <a:off x="2907360" y="4389143"/>
+            <a:ext cx="3387633" cy="201168"/>
+          </a:xfrm>
+          <a:prstGeom prst="rect">
+            <a:avLst/>
+          </a:prstGeom>
+          <a:noFill/>
+          <a:ln/>
+        </p:spPr>
+        <p:txBody>
+          <a:bodyPr wrap="square" lIns="0" tIns="0" rIns="0" bIns="0" rtlCol="0" anchor="t"/>
+          <a:lstStyle/>
+          <a:p>
+            <a:pPr algn="ctr"/>
+            <a:r>
+              <a:rPr lang="en-US" sz="900" b="1" kern="0" spc="50" dirty="0">
+                <a:solidFill>
+                  <a:srgbClr val="8250DF"/>
+                </a:solidFill>
+                <a:latin typeface="Calibri" pitchFamily="34" charset="0"/>
+                <a:ea typeface="Calibri" pitchFamily="34" charset="-122"/>
+                <a:cs typeface="Calibri" pitchFamily="34" charset="-120"/>
+              </a:rPr>
+              <a:t>https://github.com/saeed-33/interceptors_demo_guide.git</a:t>
+            </a:r>
+            <a:endParaRPr lang="en-US" sz="900" dirty="0">
+              <a:solidFill>
+                <a:srgbClr val="8250DF"/>
+              </a:solidFill>
+            </a:endParaRPr>
           </a:p>
         </p:txBody>
       </p:sp>
@@ -9515,7 +9602,7 @@
         </p:nvSpPr>
         <p:spPr>
           <a:xfrm>
-            <a:off x="1920240" y="960120"/>
+            <a:off x="1994974" y="960120"/>
             <a:ext cx="1463040" cy="685800"/>
           </a:xfrm>
           <a:prstGeom prst="roundRect">
@@ -9549,7 +9636,7 @@
         </p:nvSpPr>
         <p:spPr>
           <a:xfrm>
-            <a:off x="1920240" y="960120"/>
+            <a:off x="1994974" y="960120"/>
             <a:ext cx="1463040" cy="685800"/>
           </a:xfrm>
           <a:prstGeom prst="rect">
@@ -9605,7 +9692,7 @@
         </p:nvSpPr>
         <p:spPr>
           <a:xfrm>
-            <a:off x="3840480" y="960120"/>
+            <a:off x="3673423" y="960120"/>
             <a:ext cx="1463040" cy="685800"/>
           </a:xfrm>
           <a:prstGeom prst="roundRect">
@@ -9639,7 +9726,7 @@
         </p:nvSpPr>
         <p:spPr>
           <a:xfrm>
-            <a:off x="3840480" y="960120"/>
+            <a:off x="3673423" y="960120"/>
             <a:ext cx="1463040" cy="685800"/>
           </a:xfrm>
           <a:prstGeom prst="rect">
@@ -9695,7 +9782,7 @@
         </p:nvSpPr>
         <p:spPr>
           <a:xfrm>
-            <a:off x="5715000" y="960120"/>
+            <a:off x="5345726" y="960120"/>
             <a:ext cx="1463040" cy="685800"/>
           </a:xfrm>
           <a:prstGeom prst="roundRect">
@@ -9729,7 +9816,7 @@
         </p:nvSpPr>
         <p:spPr>
           <a:xfrm>
-            <a:off x="5715000" y="960120"/>
+            <a:off x="5345726" y="960120"/>
             <a:ext cx="1463040" cy="685800"/>
           </a:xfrm>
           <a:prstGeom prst="rect">
@@ -9785,7 +9872,7 @@
         </p:nvSpPr>
         <p:spPr>
           <a:xfrm>
-            <a:off x="7589520" y="960120"/>
+            <a:off x="7070774" y="960120"/>
             <a:ext cx="1463040" cy="685800"/>
           </a:xfrm>
           <a:prstGeom prst="roundRect">
@@ -9819,7 +9906,7 @@
         </p:nvSpPr>
         <p:spPr>
           <a:xfrm>
-            <a:off x="7589520" y="960120"/>
+            <a:off x="7070774" y="960120"/>
             <a:ext cx="1463040" cy="685800"/>
           </a:xfrm>
           <a:prstGeom prst="rect">
@@ -9858,7 +9945,7 @@
         </p:nvSpPr>
         <p:spPr>
           <a:xfrm>
-            <a:off x="1783080" y="1298448"/>
+            <a:off x="1796268" y="1298448"/>
             <a:ext cx="164592" cy="0"/>
           </a:xfrm>
           <a:prstGeom prst="line">
@@ -9888,7 +9975,7 @@
         </p:nvSpPr>
         <p:spPr>
           <a:xfrm>
-            <a:off x="1691640" y="1463040"/>
+            <a:off x="2245553" y="1463040"/>
             <a:ext cx="822960" cy="182880"/>
           </a:xfrm>
           <a:prstGeom prst="rect">
@@ -9927,7 +10014,7 @@
         </p:nvSpPr>
         <p:spPr>
           <a:xfrm>
-            <a:off x="3383280" y="1298448"/>
+            <a:off x="3471200" y="1298448"/>
             <a:ext cx="164592" cy="0"/>
           </a:xfrm>
           <a:prstGeom prst="line">
@@ -9957,7 +10044,7 @@
         </p:nvSpPr>
         <p:spPr>
           <a:xfrm>
-            <a:off x="3291840" y="1463040"/>
+            <a:off x="3977638" y="1463040"/>
             <a:ext cx="822960" cy="182880"/>
           </a:xfrm>
           <a:prstGeom prst="rect">
@@ -9996,7 +10083,7 @@
         </p:nvSpPr>
         <p:spPr>
           <a:xfrm>
-            <a:off x="5349240" y="1298448"/>
+            <a:off x="5164599" y="1298448"/>
             <a:ext cx="164592" cy="0"/>
           </a:xfrm>
           <a:prstGeom prst="line">
@@ -10026,7 +10113,7 @@
         </p:nvSpPr>
         <p:spPr>
           <a:xfrm>
-            <a:off x="5257800" y="1463040"/>
+            <a:off x="5701809" y="1463040"/>
             <a:ext cx="822960" cy="182880"/>
           </a:xfrm>
           <a:prstGeom prst="rect">
@@ -10065,7 +10152,7 @@
         </p:nvSpPr>
         <p:spPr>
           <a:xfrm>
-            <a:off x="7223760" y="1298448"/>
+            <a:off x="6872071" y="1298448"/>
             <a:ext cx="164592" cy="0"/>
           </a:xfrm>
           <a:prstGeom prst="line">
@@ -10095,7 +10182,7 @@
         </p:nvSpPr>
         <p:spPr>
           <a:xfrm>
-            <a:off x="7132320" y="1463040"/>
+            <a:off x="7334541" y="1463040"/>
             <a:ext cx="822960" cy="182880"/>
           </a:xfrm>
           <a:prstGeom prst="rect">
@@ -11532,7 +11619,7 @@
         </p:nvSpPr>
         <p:spPr>
           <a:xfrm>
-            <a:off x="274320" y="914400"/>
+            <a:off x="154574" y="914400"/>
             <a:ext cx="1225296" cy="1783080"/>
           </a:xfrm>
           <a:prstGeom prst="roundRect">
@@ -11573,7 +11660,7 @@
         </p:nvSpPr>
         <p:spPr>
           <a:xfrm>
-            <a:off x="274320" y="914400"/>
+            <a:off x="154574" y="914400"/>
             <a:ext cx="1225296" cy="292608"/>
           </a:xfrm>
           <a:prstGeom prst="roundRect">
@@ -11609,7 +11696,7 @@
         </p:nvSpPr>
         <p:spPr>
           <a:xfrm>
-            <a:off x="274320" y="1280160"/>
+            <a:off x="154574" y="1280160"/>
             <a:ext cx="1225296" cy="658368"/>
           </a:xfrm>
           <a:prstGeom prst="rect">
@@ -11648,7 +11735,7 @@
         </p:nvSpPr>
         <p:spPr>
           <a:xfrm>
-            <a:off x="274320" y="2029968"/>
+            <a:off x="154574" y="2029968"/>
             <a:ext cx="1225296" cy="310896"/>
           </a:xfrm>
           <a:prstGeom prst="rect">
@@ -11687,7 +11774,7 @@
         </p:nvSpPr>
         <p:spPr>
           <a:xfrm>
-            <a:off x="274320" y="2340864"/>
+            <a:off x="154574" y="2340864"/>
             <a:ext cx="1225296" cy="219456"/>
           </a:xfrm>
           <a:prstGeom prst="rect">
@@ -11726,7 +11813,7 @@
         </p:nvSpPr>
         <p:spPr>
           <a:xfrm>
-            <a:off x="1554480" y="914400"/>
+            <a:off x="1434734" y="914400"/>
             <a:ext cx="1225296" cy="1783080"/>
           </a:xfrm>
           <a:prstGeom prst="roundRect">
@@ -11767,7 +11854,7 @@
         </p:nvSpPr>
         <p:spPr>
           <a:xfrm>
-            <a:off x="1554480" y="914400"/>
+            <a:off x="1434734" y="914400"/>
             <a:ext cx="1225296" cy="292608"/>
           </a:xfrm>
           <a:prstGeom prst="roundRect">
@@ -11803,7 +11890,7 @@
         </p:nvSpPr>
         <p:spPr>
           <a:xfrm>
-            <a:off x="1554480" y="1280160"/>
+            <a:off x="1434734" y="1280160"/>
             <a:ext cx="1225296" cy="658368"/>
           </a:xfrm>
           <a:prstGeom prst="rect">
@@ -11842,7 +11929,7 @@
         </p:nvSpPr>
         <p:spPr>
           <a:xfrm>
-            <a:off x="1554480" y="2029968"/>
+            <a:off x="1434734" y="2029968"/>
             <a:ext cx="1225296" cy="310896"/>
           </a:xfrm>
           <a:prstGeom prst="rect">
@@ -11881,7 +11968,7 @@
         </p:nvSpPr>
         <p:spPr>
           <a:xfrm>
-            <a:off x="1554480" y="2340864"/>
+            <a:off x="1434734" y="2340864"/>
             <a:ext cx="1225296" cy="219456"/>
           </a:xfrm>
           <a:prstGeom prst="rect">
@@ -11920,7 +12007,7 @@
         </p:nvSpPr>
         <p:spPr>
           <a:xfrm>
-            <a:off x="2834640" y="914400"/>
+            <a:off x="2714894" y="914400"/>
             <a:ext cx="1225296" cy="1783080"/>
           </a:xfrm>
           <a:prstGeom prst="roundRect">
@@ -11961,7 +12048,7 @@
         </p:nvSpPr>
         <p:spPr>
           <a:xfrm>
-            <a:off x="2834640" y="914400"/>
+            <a:off x="2714894" y="914400"/>
             <a:ext cx="1225296" cy="292608"/>
           </a:xfrm>
           <a:prstGeom prst="roundRect">
@@ -11997,7 +12084,7 @@
         </p:nvSpPr>
         <p:spPr>
           <a:xfrm>
-            <a:off x="2834640" y="1280160"/>
+            <a:off x="2714894" y="1280160"/>
             <a:ext cx="1225296" cy="658368"/>
           </a:xfrm>
           <a:prstGeom prst="rect">
@@ -12036,7 +12123,7 @@
         </p:nvSpPr>
         <p:spPr>
           <a:xfrm>
-            <a:off x="2834640" y="2029968"/>
+            <a:off x="2714894" y="2029968"/>
             <a:ext cx="1225296" cy="310896"/>
           </a:xfrm>
           <a:prstGeom prst="rect">
@@ -12075,7 +12162,7 @@
         </p:nvSpPr>
         <p:spPr>
           <a:xfrm>
-            <a:off x="2834640" y="2340864"/>
+            <a:off x="2714894" y="2340864"/>
             <a:ext cx="1225296" cy="219456"/>
           </a:xfrm>
           <a:prstGeom prst="rect">
@@ -12114,7 +12201,7 @@
         </p:nvSpPr>
         <p:spPr>
           <a:xfrm>
-            <a:off x="4114800" y="914400"/>
+            <a:off x="3995054" y="914400"/>
             <a:ext cx="1225296" cy="1783080"/>
           </a:xfrm>
           <a:prstGeom prst="roundRect">
@@ -12155,7 +12242,7 @@
         </p:nvSpPr>
         <p:spPr>
           <a:xfrm>
-            <a:off x="4114800" y="914400"/>
+            <a:off x="3995054" y="914400"/>
             <a:ext cx="1225296" cy="292608"/>
           </a:xfrm>
           <a:prstGeom prst="roundRect">
@@ -12191,7 +12278,7 @@
         </p:nvSpPr>
         <p:spPr>
           <a:xfrm>
-            <a:off x="4114800" y="1280160"/>
+            <a:off x="3995054" y="1280160"/>
             <a:ext cx="1225296" cy="658368"/>
           </a:xfrm>
           <a:prstGeom prst="rect">
@@ -12230,7 +12317,7 @@
         </p:nvSpPr>
         <p:spPr>
           <a:xfrm>
-            <a:off x="4114800" y="2029968"/>
+            <a:off x="3995054" y="2029968"/>
             <a:ext cx="1225296" cy="310896"/>
           </a:xfrm>
           <a:prstGeom prst="rect">
@@ -12269,7 +12356,7 @@
         </p:nvSpPr>
         <p:spPr>
           <a:xfrm>
-            <a:off x="4114800" y="2340864"/>
+            <a:off x="3995054" y="2340864"/>
             <a:ext cx="1225296" cy="219456"/>
           </a:xfrm>
           <a:prstGeom prst="rect">
@@ -12308,7 +12395,7 @@
         </p:nvSpPr>
         <p:spPr>
           <a:xfrm>
-            <a:off x="5394960" y="914400"/>
+            <a:off x="5275214" y="914400"/>
             <a:ext cx="1225296" cy="1783080"/>
           </a:xfrm>
           <a:prstGeom prst="roundRect">
@@ -12349,7 +12436,7 @@
         </p:nvSpPr>
         <p:spPr>
           <a:xfrm>
-            <a:off x="5394960" y="914400"/>
+            <a:off x="5275214" y="914400"/>
             <a:ext cx="1225296" cy="292608"/>
           </a:xfrm>
           <a:prstGeom prst="roundRect">
@@ -12385,7 +12472,7 @@
         </p:nvSpPr>
         <p:spPr>
           <a:xfrm>
-            <a:off x="5394960" y="1280160"/>
+            <a:off x="5275214" y="1280160"/>
             <a:ext cx="1225296" cy="658368"/>
           </a:xfrm>
           <a:prstGeom prst="rect">
@@ -12424,7 +12511,7 @@
         </p:nvSpPr>
         <p:spPr>
           <a:xfrm>
-            <a:off x="5394960" y="2029968"/>
+            <a:off x="5275214" y="2029968"/>
             <a:ext cx="1225296" cy="310896"/>
           </a:xfrm>
           <a:prstGeom prst="rect">
@@ -12463,7 +12550,7 @@
         </p:nvSpPr>
         <p:spPr>
           <a:xfrm>
-            <a:off x="5394960" y="2340864"/>
+            <a:off x="5275214" y="2340864"/>
             <a:ext cx="1225296" cy="219456"/>
           </a:xfrm>
           <a:prstGeom prst="rect">
@@ -12502,7 +12589,7 @@
         </p:nvSpPr>
         <p:spPr>
           <a:xfrm>
-            <a:off x="6675120" y="914400"/>
+            <a:off x="6555374" y="914400"/>
             <a:ext cx="1225296" cy="1783080"/>
           </a:xfrm>
           <a:prstGeom prst="roundRect">
@@ -12543,7 +12630,7 @@
         </p:nvSpPr>
         <p:spPr>
           <a:xfrm>
-            <a:off x="6675120" y="914400"/>
+            <a:off x="6555374" y="914400"/>
             <a:ext cx="1225296" cy="292608"/>
           </a:xfrm>
           <a:prstGeom prst="roundRect">
@@ -12579,7 +12666,7 @@
         </p:nvSpPr>
         <p:spPr>
           <a:xfrm>
-            <a:off x="6675120" y="1280160"/>
+            <a:off x="6555374" y="1280160"/>
             <a:ext cx="1225296" cy="658368"/>
           </a:xfrm>
           <a:prstGeom prst="rect">
@@ -12618,7 +12705,7 @@
         </p:nvSpPr>
         <p:spPr>
           <a:xfrm>
-            <a:off x="6675120" y="2029968"/>
+            <a:off x="6555374" y="2029968"/>
             <a:ext cx="1225296" cy="310896"/>
           </a:xfrm>
           <a:prstGeom prst="rect">
@@ -12657,7 +12744,7 @@
         </p:nvSpPr>
         <p:spPr>
           <a:xfrm>
-            <a:off x="6675120" y="2340864"/>
+            <a:off x="6555374" y="2340864"/>
             <a:ext cx="1225296" cy="219456"/>
           </a:xfrm>
           <a:prstGeom prst="rect">
@@ -12696,7 +12783,7 @@
         </p:nvSpPr>
         <p:spPr>
           <a:xfrm>
-            <a:off x="7955280" y="914400"/>
+            <a:off x="7835534" y="914400"/>
             <a:ext cx="1225296" cy="1783080"/>
           </a:xfrm>
           <a:prstGeom prst="roundRect">
@@ -12737,7 +12824,7 @@
         </p:nvSpPr>
         <p:spPr>
           <a:xfrm>
-            <a:off x="7955280" y="914400"/>
+            <a:off x="7835534" y="914400"/>
             <a:ext cx="1225296" cy="292608"/>
           </a:xfrm>
           <a:prstGeom prst="roundRect">
@@ -12773,7 +12860,7 @@
         </p:nvSpPr>
         <p:spPr>
           <a:xfrm>
-            <a:off x="7955280" y="1280160"/>
+            <a:off x="7835534" y="1280160"/>
             <a:ext cx="1225296" cy="658368"/>
           </a:xfrm>
           <a:prstGeom prst="rect">
@@ -12812,7 +12899,7 @@
         </p:nvSpPr>
         <p:spPr>
           <a:xfrm>
-            <a:off x="7955280" y="2029968"/>
+            <a:off x="7835534" y="2029968"/>
             <a:ext cx="1225296" cy="310896"/>
           </a:xfrm>
           <a:prstGeom prst="rect">
@@ -12851,7 +12938,7 @@
         </p:nvSpPr>
         <p:spPr>
           <a:xfrm>
-            <a:off x="7955280" y="2340864"/>
+            <a:off x="7835534" y="2340864"/>
             <a:ext cx="1225296" cy="219456"/>
           </a:xfrm>
           <a:prstGeom prst="rect">
@@ -12890,7 +12977,7 @@
         </p:nvSpPr>
         <p:spPr>
           <a:xfrm>
-            <a:off x="274320" y="2770632"/>
+            <a:off x="154574" y="2770632"/>
             <a:ext cx="1225296" cy="1783080"/>
           </a:xfrm>
           <a:prstGeom prst="roundRect">
@@ -12931,7 +13018,7 @@
         </p:nvSpPr>
         <p:spPr>
           <a:xfrm>
-            <a:off x="274320" y="2770632"/>
+            <a:off x="154574" y="2770632"/>
             <a:ext cx="1225296" cy="292608"/>
           </a:xfrm>
           <a:prstGeom prst="roundRect">
@@ -12967,7 +13054,7 @@
         </p:nvSpPr>
         <p:spPr>
           <a:xfrm>
-            <a:off x="274320" y="3136392"/>
+            <a:off x="154574" y="3136392"/>
             <a:ext cx="1225296" cy="658368"/>
           </a:xfrm>
           <a:prstGeom prst="rect">
@@ -13006,7 +13093,7 @@
         </p:nvSpPr>
         <p:spPr>
           <a:xfrm>
-            <a:off x="274320" y="3886200"/>
+            <a:off x="154574" y="3886200"/>
             <a:ext cx="1225296" cy="310896"/>
           </a:xfrm>
           <a:prstGeom prst="rect">
@@ -13045,7 +13132,7 @@
         </p:nvSpPr>
         <p:spPr>
           <a:xfrm>
-            <a:off x="274320" y="4197096"/>
+            <a:off x="154574" y="4197096"/>
             <a:ext cx="1225296" cy="219456"/>
           </a:xfrm>
           <a:prstGeom prst="rect">
@@ -13084,7 +13171,7 @@
         </p:nvSpPr>
         <p:spPr>
           <a:xfrm>
-            <a:off x="1554480" y="2770632"/>
+            <a:off x="1434734" y="2770632"/>
             <a:ext cx="1225296" cy="1783080"/>
           </a:xfrm>
           <a:prstGeom prst="roundRect">
@@ -13125,7 +13212,7 @@
         </p:nvSpPr>
         <p:spPr>
           <a:xfrm>
-            <a:off x="1554480" y="2770632"/>
+            <a:off x="1434734" y="2770632"/>
             <a:ext cx="1225296" cy="292608"/>
           </a:xfrm>
           <a:prstGeom prst="roundRect">
@@ -13161,7 +13248,7 @@
         </p:nvSpPr>
         <p:spPr>
           <a:xfrm>
-            <a:off x="1554480" y="3136392"/>
+            <a:off x="1434734" y="3136392"/>
             <a:ext cx="1225296" cy="658368"/>
           </a:xfrm>
           <a:prstGeom prst="rect">
@@ -13200,7 +13287,7 @@
         </p:nvSpPr>
         <p:spPr>
           <a:xfrm>
-            <a:off x="1554480" y="3886200"/>
+            <a:off x="1434734" y="3886200"/>
             <a:ext cx="1225296" cy="310896"/>
           </a:xfrm>
           <a:prstGeom prst="rect">
@@ -13239,7 +13326,7 @@
         </p:nvSpPr>
         <p:spPr>
           <a:xfrm>
-            <a:off x="1554480" y="4197096"/>
+            <a:off x="1434734" y="4197096"/>
             <a:ext cx="1225296" cy="219456"/>
           </a:xfrm>
           <a:prstGeom prst="rect">
@@ -13278,7 +13365,7 @@
         </p:nvSpPr>
         <p:spPr>
           <a:xfrm>
-            <a:off x="2834640" y="2770632"/>
+            <a:off x="2714894" y="2770632"/>
             <a:ext cx="1225296" cy="1783080"/>
           </a:xfrm>
           <a:prstGeom prst="roundRect">
@@ -13319,7 +13406,7 @@
         </p:nvSpPr>
         <p:spPr>
           <a:xfrm>
-            <a:off x="2834640" y="2770632"/>
+            <a:off x="2714894" y="2770632"/>
             <a:ext cx="1225296" cy="292608"/>
           </a:xfrm>
           <a:prstGeom prst="roundRect">
@@ -13355,7 +13442,7 @@
         </p:nvSpPr>
         <p:spPr>
           <a:xfrm>
-            <a:off x="2834640" y="3136392"/>
+            <a:off x="2714894" y="3136392"/>
             <a:ext cx="1225296" cy="658368"/>
           </a:xfrm>
           <a:prstGeom prst="rect">
@@ -13394,7 +13481,7 @@
         </p:nvSpPr>
         <p:spPr>
           <a:xfrm>
-            <a:off x="2834640" y="3886200"/>
+            <a:off x="2714894" y="3886200"/>
             <a:ext cx="1225296" cy="310896"/>
           </a:xfrm>
           <a:prstGeom prst="rect">
@@ -13433,7 +13520,7 @@
         </p:nvSpPr>
         <p:spPr>
           <a:xfrm>
-            <a:off x="2834640" y="4197096"/>
+            <a:off x="2714894" y="4197096"/>
             <a:ext cx="1225296" cy="219456"/>
           </a:xfrm>
           <a:prstGeom prst="rect">
@@ -13472,7 +13559,7 @@
         </p:nvSpPr>
         <p:spPr>
           <a:xfrm>
-            <a:off x="4114800" y="2770632"/>
+            <a:off x="3995054" y="2770632"/>
             <a:ext cx="1225296" cy="1783080"/>
           </a:xfrm>
           <a:prstGeom prst="roundRect">
@@ -13513,7 +13600,7 @@
         </p:nvSpPr>
         <p:spPr>
           <a:xfrm>
-            <a:off x="4114800" y="2770632"/>
+            <a:off x="3995054" y="2770632"/>
             <a:ext cx="1225296" cy="292608"/>
           </a:xfrm>
           <a:prstGeom prst="roundRect">
@@ -13549,7 +13636,7 @@
         </p:nvSpPr>
         <p:spPr>
           <a:xfrm>
-            <a:off x="4114800" y="3136392"/>
+            <a:off x="3995054" y="3136392"/>
             <a:ext cx="1225296" cy="658368"/>
           </a:xfrm>
           <a:prstGeom prst="rect">
@@ -13588,7 +13675,7 @@
         </p:nvSpPr>
         <p:spPr>
           <a:xfrm>
-            <a:off x="4114800" y="3886200"/>
+            <a:off x="3995054" y="3886200"/>
             <a:ext cx="1225296" cy="310896"/>
           </a:xfrm>
           <a:prstGeom prst="rect">
@@ -13627,7 +13714,7 @@
         </p:nvSpPr>
         <p:spPr>
           <a:xfrm>
-            <a:off x="4114800" y="4197096"/>
+            <a:off x="3995054" y="4197096"/>
             <a:ext cx="1225296" cy="219456"/>
           </a:xfrm>
           <a:prstGeom prst="rect">
@@ -13666,7 +13753,7 @@
         </p:nvSpPr>
         <p:spPr>
           <a:xfrm>
-            <a:off x="5394960" y="2770632"/>
+            <a:off x="5275214" y="2770632"/>
             <a:ext cx="1225296" cy="1783080"/>
           </a:xfrm>
           <a:prstGeom prst="roundRect">
@@ -13707,7 +13794,7 @@
         </p:nvSpPr>
         <p:spPr>
           <a:xfrm>
-            <a:off x="5394960" y="2770632"/>
+            <a:off x="5275214" y="2770632"/>
             <a:ext cx="1225296" cy="292608"/>
           </a:xfrm>
           <a:prstGeom prst="roundRect">
@@ -13743,7 +13830,7 @@
         </p:nvSpPr>
         <p:spPr>
           <a:xfrm>
-            <a:off x="5394960" y="3136392"/>
+            <a:off x="5275214" y="3136392"/>
             <a:ext cx="1225296" cy="658368"/>
           </a:xfrm>
           <a:prstGeom prst="rect">
@@ -13782,7 +13869,7 @@
         </p:nvSpPr>
         <p:spPr>
           <a:xfrm>
-            <a:off x="5394960" y="3886200"/>
+            <a:off x="5275214" y="3886200"/>
             <a:ext cx="1225296" cy="310896"/>
           </a:xfrm>
           <a:prstGeom prst="rect">
@@ -13821,7 +13908,7 @@
         </p:nvSpPr>
         <p:spPr>
           <a:xfrm>
-            <a:off x="5394960" y="4197096"/>
+            <a:off x="5275214" y="4197096"/>
             <a:ext cx="1225296" cy="219456"/>
           </a:xfrm>
           <a:prstGeom prst="rect">
@@ -13860,7 +13947,7 @@
         </p:nvSpPr>
         <p:spPr>
           <a:xfrm>
-            <a:off x="6675120" y="2770632"/>
+            <a:off x="6555374" y="2770632"/>
             <a:ext cx="1225296" cy="1783080"/>
           </a:xfrm>
           <a:prstGeom prst="roundRect">
@@ -13901,7 +13988,7 @@
         </p:nvSpPr>
         <p:spPr>
           <a:xfrm>
-            <a:off x="6675120" y="2770632"/>
+            <a:off x="6555374" y="2770632"/>
             <a:ext cx="1225296" cy="292608"/>
           </a:xfrm>
           <a:prstGeom prst="roundRect">
@@ -13937,7 +14024,7 @@
         </p:nvSpPr>
         <p:spPr>
           <a:xfrm>
-            <a:off x="6675120" y="3136392"/>
+            <a:off x="6555374" y="3136392"/>
             <a:ext cx="1225296" cy="658368"/>
           </a:xfrm>
           <a:prstGeom prst="rect">
@@ -13976,7 +14063,7 @@
         </p:nvSpPr>
         <p:spPr>
           <a:xfrm>
-            <a:off x="6675120" y="3886200"/>
+            <a:off x="6555374" y="3886200"/>
             <a:ext cx="1225296" cy="310896"/>
           </a:xfrm>
           <a:prstGeom prst="rect">
@@ -14015,7 +14102,7 @@
         </p:nvSpPr>
         <p:spPr>
           <a:xfrm>
-            <a:off x="6675120" y="4197096"/>
+            <a:off x="6555374" y="4197096"/>
             <a:ext cx="1225296" cy="219456"/>
           </a:xfrm>
           <a:prstGeom prst="rect">
@@ -14054,7 +14141,7 @@
         </p:nvSpPr>
         <p:spPr>
           <a:xfrm>
-            <a:off x="7955280" y="2770632"/>
+            <a:off x="7835534" y="2770632"/>
             <a:ext cx="1225296" cy="1783080"/>
           </a:xfrm>
           <a:prstGeom prst="roundRect">
@@ -14095,7 +14182,7 @@
         </p:nvSpPr>
         <p:spPr>
           <a:xfrm>
-            <a:off x="7955280" y="2770632"/>
+            <a:off x="7835534" y="2770632"/>
             <a:ext cx="1225296" cy="292608"/>
           </a:xfrm>
           <a:prstGeom prst="roundRect">
@@ -14131,7 +14218,7 @@
         </p:nvSpPr>
         <p:spPr>
           <a:xfrm>
-            <a:off x="7955280" y="3136392"/>
+            <a:off x="7835534" y="3136392"/>
             <a:ext cx="1225296" cy="658368"/>
           </a:xfrm>
           <a:prstGeom prst="rect">
@@ -14170,7 +14257,7 @@
         </p:nvSpPr>
         <p:spPr>
           <a:xfrm>
-            <a:off x="7955280" y="3886200"/>
+            <a:off x="7835534" y="3886200"/>
             <a:ext cx="1225296" cy="310896"/>
           </a:xfrm>
           <a:prstGeom prst="rect">
@@ -14209,7 +14296,7 @@
         </p:nvSpPr>
         <p:spPr>
           <a:xfrm>
-            <a:off x="7955280" y="4197096"/>
+            <a:off x="7835534" y="4197096"/>
             <a:ext cx="1225296" cy="219456"/>
           </a:xfrm>
           <a:prstGeom prst="rect">

</xml_diff>